<commit_message>
feature selection and hyperparameter tuning
</commit_message>
<xml_diff>
--- a/Presentation 1 to 8.pptx
+++ b/Presentation 1 to 8.pptx
@@ -637,7 +637,7 @@
           <a:p>
             <a:fld id="{FD74747F-D400-4A90-89D9-3448D815F5DF}" type="datetimeFigureOut">
               <a:rPr lang="en-IN" smtClean="0"/>
-              <a:t>06-03-2026</a:t>
+              <a:t>20-03-2026</a:t>
             </a:fld>
             <a:endParaRPr lang="en-IN"/>
           </a:p>
@@ -933,7 +933,7 @@
           <a:p>
             <a:fld id="{FD74747F-D400-4A90-89D9-3448D815F5DF}" type="datetimeFigureOut">
               <a:rPr lang="en-IN" smtClean="0"/>
-              <a:t>06-03-2026</a:t>
+              <a:t>20-03-2026</a:t>
             </a:fld>
             <a:endParaRPr lang="en-IN"/>
           </a:p>
@@ -1181,7 +1181,7 @@
           <a:p>
             <a:fld id="{FD74747F-D400-4A90-89D9-3448D815F5DF}" type="datetimeFigureOut">
               <a:rPr lang="en-IN" smtClean="0"/>
-              <a:t>06-03-2026</a:t>
+              <a:t>20-03-2026</a:t>
             </a:fld>
             <a:endParaRPr lang="en-IN"/>
           </a:p>
@@ -1721,7 +1721,7 @@
           <a:p>
             <a:fld id="{FD74747F-D400-4A90-89D9-3448D815F5DF}" type="datetimeFigureOut">
               <a:rPr lang="en-IN" smtClean="0"/>
-              <a:t>06-03-2026</a:t>
+              <a:t>20-03-2026</a:t>
             </a:fld>
             <a:endParaRPr lang="en-IN"/>
           </a:p>
@@ -1969,7 +1969,7 @@
           <a:p>
             <a:fld id="{FD74747F-D400-4A90-89D9-3448D815F5DF}" type="datetimeFigureOut">
               <a:rPr lang="en-IN" smtClean="0"/>
-              <a:t>06-03-2026</a:t>
+              <a:t>20-03-2026</a:t>
             </a:fld>
             <a:endParaRPr lang="en-IN"/>
           </a:p>
@@ -2501,7 +2501,7 @@
           <a:p>
             <a:fld id="{FD74747F-D400-4A90-89D9-3448D815F5DF}" type="datetimeFigureOut">
               <a:rPr lang="en-IN" smtClean="0"/>
-              <a:t>06-03-2026</a:t>
+              <a:t>20-03-2026</a:t>
             </a:fld>
             <a:endParaRPr lang="en-IN"/>
           </a:p>
@@ -2798,7 +2798,7 @@
           <a:p>
             <a:fld id="{FD74747F-D400-4A90-89D9-3448D815F5DF}" type="datetimeFigureOut">
               <a:rPr lang="en-IN" smtClean="0"/>
-              <a:t>06-03-2026</a:t>
+              <a:t>20-03-2026</a:t>
             </a:fld>
             <a:endParaRPr lang="en-IN"/>
           </a:p>
@@ -2972,7 +2972,7 @@
           <a:p>
             <a:fld id="{FD74747F-D400-4A90-89D9-3448D815F5DF}" type="datetimeFigureOut">
               <a:rPr lang="en-IN" smtClean="0"/>
-              <a:t>06-03-2026</a:t>
+              <a:t>20-03-2026</a:t>
             </a:fld>
             <a:endParaRPr lang="en-IN"/>
           </a:p>
@@ -3152,7 +3152,7 @@
           <a:p>
             <a:fld id="{FD74747F-D400-4A90-89D9-3448D815F5DF}" type="datetimeFigureOut">
               <a:rPr lang="en-IN" smtClean="0"/>
-              <a:t>06-03-2026</a:t>
+              <a:t>20-03-2026</a:t>
             </a:fld>
             <a:endParaRPr lang="en-IN"/>
           </a:p>
@@ -3322,7 +3322,7 @@
           <a:p>
             <a:fld id="{FD74747F-D400-4A90-89D9-3448D815F5DF}" type="datetimeFigureOut">
               <a:rPr lang="en-IN" smtClean="0"/>
-              <a:t>06-03-2026</a:t>
+              <a:t>20-03-2026</a:t>
             </a:fld>
             <a:endParaRPr lang="en-IN"/>
           </a:p>
@@ -3573,7 +3573,7 @@
           <a:p>
             <a:fld id="{FD74747F-D400-4A90-89D9-3448D815F5DF}" type="datetimeFigureOut">
               <a:rPr lang="en-IN" smtClean="0"/>
-              <a:t>06-03-2026</a:t>
+              <a:t>20-03-2026</a:t>
             </a:fld>
             <a:endParaRPr lang="en-IN"/>
           </a:p>
@@ -3870,7 +3870,7 @@
           <a:p>
             <a:fld id="{FD74747F-D400-4A90-89D9-3448D815F5DF}" type="datetimeFigureOut">
               <a:rPr lang="en-IN" smtClean="0"/>
-              <a:t>06-03-2026</a:t>
+              <a:t>20-03-2026</a:t>
             </a:fld>
             <a:endParaRPr lang="en-IN"/>
           </a:p>
@@ -4312,7 +4312,7 @@
           <a:p>
             <a:fld id="{FD74747F-D400-4A90-89D9-3448D815F5DF}" type="datetimeFigureOut">
               <a:rPr lang="en-IN" smtClean="0"/>
-              <a:t>06-03-2026</a:t>
+              <a:t>20-03-2026</a:t>
             </a:fld>
             <a:endParaRPr lang="en-IN"/>
           </a:p>
@@ -4430,7 +4430,7 @@
           <a:p>
             <a:fld id="{FD74747F-D400-4A90-89D9-3448D815F5DF}" type="datetimeFigureOut">
               <a:rPr lang="en-IN" smtClean="0"/>
-              <a:t>06-03-2026</a:t>
+              <a:t>20-03-2026</a:t>
             </a:fld>
             <a:endParaRPr lang="en-IN"/>
           </a:p>
@@ -4525,7 +4525,7 @@
           <a:p>
             <a:fld id="{FD74747F-D400-4A90-89D9-3448D815F5DF}" type="datetimeFigureOut">
               <a:rPr lang="en-IN" smtClean="0"/>
-              <a:t>06-03-2026</a:t>
+              <a:t>20-03-2026</a:t>
             </a:fld>
             <a:endParaRPr lang="en-IN"/>
           </a:p>
@@ -4808,7 +4808,7 @@
           <a:p>
             <a:fld id="{FD74747F-D400-4A90-89D9-3448D815F5DF}" type="datetimeFigureOut">
               <a:rPr lang="en-IN" smtClean="0"/>
-              <a:t>06-03-2026</a:t>
+              <a:t>20-03-2026</a:t>
             </a:fld>
             <a:endParaRPr lang="en-IN"/>
           </a:p>
@@ -5099,7 +5099,7 @@
           <a:p>
             <a:fld id="{FD74747F-D400-4A90-89D9-3448D815F5DF}" type="datetimeFigureOut">
               <a:rPr lang="en-IN" smtClean="0"/>
-              <a:t>06-03-2026</a:t>
+              <a:t>20-03-2026</a:t>
             </a:fld>
             <a:endParaRPr lang="en-IN"/>
           </a:p>
@@ -5629,7 +5629,7 @@
           <a:p>
             <a:fld id="{FD74747F-D400-4A90-89D9-3448D815F5DF}" type="datetimeFigureOut">
               <a:rPr lang="en-IN" smtClean="0"/>
-              <a:t>06-03-2026</a:t>
+              <a:t>20-03-2026</a:t>
             </a:fld>
             <a:endParaRPr lang="en-IN"/>
           </a:p>
@@ -9455,14 +9455,14 @@
       </p:grpSpPr>
       <p:sp>
         <p:nvSpPr>
-          <p:cNvPr id="2" name="TextBox 1"/>
+          <p:cNvPr id="4" name="TextBox 3"/>
           <p:cNvSpPr txBox="1"/>
           <p:nvPr/>
         </p:nvSpPr>
         <p:spPr>
           <a:xfrm>
-            <a:off x="2716696" y="1298713"/>
-            <a:ext cx="8388626" cy="5262979"/>
+            <a:off x="2014330" y="357809"/>
+            <a:ext cx="2464904" cy="400110"/>
           </a:xfrm>
           <a:prstGeom prst="rect">
             <a:avLst/>
@@ -9475,171 +9475,14 @@
           </a:bodyPr>
           <a:lstStyle/>
           <a:p>
-            <a:pPr marL="342900" indent="-342900">
-              <a:buFont typeface="Arial" panose="020B0604020202020204" pitchFamily="34" charset="0"/>
-              <a:buChar char="•"/>
-            </a:pPr>
-            <a:r>
-              <a:rPr lang="en-US" sz="2400" dirty="0" smtClean="0">
-                <a:latin typeface="Times New Roman" panose="02020603050405020304" pitchFamily="18" charset="0"/>
-                <a:cs typeface="Times New Roman" panose="02020603050405020304" pitchFamily="18" charset="0"/>
-              </a:rPr>
-              <a:t>To measure classification performance, we use different evaluation metrics.</a:t>
-            </a:r>
-          </a:p>
-          <a:p>
-            <a:pPr marL="342900" indent="-342900">
-              <a:buFont typeface="Arial" panose="020B0604020202020204" pitchFamily="34" charset="0"/>
-              <a:buChar char="•"/>
-            </a:pPr>
-            <a:r>
-              <a:rPr lang="en-US" sz="2400" dirty="0" smtClean="0">
-                <a:latin typeface="Times New Roman" panose="02020603050405020304" pitchFamily="18" charset="0"/>
-                <a:cs typeface="Times New Roman" panose="02020603050405020304" pitchFamily="18" charset="0"/>
-              </a:rPr>
-              <a:t>The </a:t>
-            </a:r>
-            <a:r>
-              <a:rPr lang="en-US" sz="2400" b="1" dirty="0" smtClean="0">
-                <a:latin typeface="Times New Roman" panose="02020603050405020304" pitchFamily="18" charset="0"/>
-                <a:cs typeface="Times New Roman" panose="02020603050405020304" pitchFamily="18" charset="0"/>
-              </a:rPr>
-              <a:t>Confusion Matrix</a:t>
-            </a:r>
-            <a:r>
-              <a:rPr lang="en-US" sz="2400" dirty="0" smtClean="0">
-                <a:latin typeface="Times New Roman" panose="02020603050405020304" pitchFamily="18" charset="0"/>
-                <a:cs typeface="Times New Roman" panose="02020603050405020304" pitchFamily="18" charset="0"/>
-              </a:rPr>
-              <a:t> shows:</a:t>
-            </a:r>
-          </a:p>
-          <a:p>
-            <a:r>
-              <a:rPr lang="en-US" sz="2400" dirty="0" smtClean="0">
-                <a:latin typeface="Times New Roman" panose="02020603050405020304" pitchFamily="18" charset="0"/>
-                <a:cs typeface="Times New Roman" panose="02020603050405020304" pitchFamily="18" charset="0"/>
-              </a:rPr>
-              <a:t>True Positive (TP)</a:t>
-            </a:r>
-          </a:p>
-          <a:p>
-            <a:r>
-              <a:rPr lang="en-US" sz="2400" dirty="0" smtClean="0">
-                <a:latin typeface="Times New Roman" panose="02020603050405020304" pitchFamily="18" charset="0"/>
-                <a:cs typeface="Times New Roman" panose="02020603050405020304" pitchFamily="18" charset="0"/>
-              </a:rPr>
-              <a:t>True Negative (TN)</a:t>
-            </a:r>
-          </a:p>
-          <a:p>
-            <a:r>
-              <a:rPr lang="en-US" sz="2400" dirty="0" smtClean="0">
-                <a:latin typeface="Times New Roman" panose="02020603050405020304" pitchFamily="18" charset="0"/>
-                <a:cs typeface="Times New Roman" panose="02020603050405020304" pitchFamily="18" charset="0"/>
-              </a:rPr>
-              <a:t>False Positive (FP)</a:t>
-            </a:r>
-          </a:p>
-          <a:p>
-            <a:r>
-              <a:rPr lang="en-US" sz="2400" dirty="0" smtClean="0">
-                <a:latin typeface="Times New Roman" panose="02020603050405020304" pitchFamily="18" charset="0"/>
-                <a:cs typeface="Times New Roman" panose="02020603050405020304" pitchFamily="18" charset="0"/>
-              </a:rPr>
-              <a:t>False Negative (FN)</a:t>
-            </a:r>
-          </a:p>
-          <a:p>
-            <a:pPr marL="342900" indent="-342900">
-              <a:buFont typeface="Arial" panose="020B0604020202020204" pitchFamily="34" charset="0"/>
-              <a:buChar char="•"/>
-            </a:pPr>
-            <a:r>
-              <a:rPr lang="en-US" sz="2400" dirty="0" smtClean="0">
-                <a:latin typeface="Times New Roman" panose="02020603050405020304" pitchFamily="18" charset="0"/>
-                <a:cs typeface="Times New Roman" panose="02020603050405020304" pitchFamily="18" charset="0"/>
-              </a:rPr>
-              <a:t>Key metrics include:</a:t>
-            </a:r>
-          </a:p>
-          <a:p>
-            <a:r>
-              <a:rPr lang="en-US" sz="2400" b="1" dirty="0" smtClean="0">
-                <a:latin typeface="Times New Roman" panose="02020603050405020304" pitchFamily="18" charset="0"/>
-                <a:cs typeface="Times New Roman" panose="02020603050405020304" pitchFamily="18" charset="0"/>
-              </a:rPr>
-              <a:t>Accuracy</a:t>
-            </a:r>
-            <a:r>
-              <a:rPr lang="en-US" sz="2400" dirty="0" smtClean="0">
-                <a:latin typeface="Times New Roman" panose="02020603050405020304" pitchFamily="18" charset="0"/>
-                <a:cs typeface="Times New Roman" panose="02020603050405020304" pitchFamily="18" charset="0"/>
-              </a:rPr>
-              <a:t> – Overall correct predictions</a:t>
-            </a:r>
-          </a:p>
-          <a:p>
-            <a:r>
-              <a:rPr lang="en-US" sz="2400" b="1" dirty="0" smtClean="0">
-                <a:latin typeface="Times New Roman" panose="02020603050405020304" pitchFamily="18" charset="0"/>
-                <a:cs typeface="Times New Roman" panose="02020603050405020304" pitchFamily="18" charset="0"/>
-              </a:rPr>
-              <a:t>Precision</a:t>
-            </a:r>
-            <a:r>
-              <a:rPr lang="en-US" sz="2400" dirty="0" smtClean="0">
-                <a:latin typeface="Times New Roman" panose="02020603050405020304" pitchFamily="18" charset="0"/>
-                <a:cs typeface="Times New Roman" panose="02020603050405020304" pitchFamily="18" charset="0"/>
-              </a:rPr>
-              <a:t> – How many predicted positives are actually correct</a:t>
-            </a:r>
-          </a:p>
-          <a:p>
-            <a:r>
-              <a:rPr lang="en-US" sz="2400" b="1" dirty="0" smtClean="0">
-                <a:latin typeface="Times New Roman" panose="02020603050405020304" pitchFamily="18" charset="0"/>
-                <a:cs typeface="Times New Roman" panose="02020603050405020304" pitchFamily="18" charset="0"/>
-              </a:rPr>
-              <a:t>Recall</a:t>
-            </a:r>
-            <a:r>
-              <a:rPr lang="en-US" sz="2400" dirty="0" smtClean="0">
-                <a:latin typeface="Times New Roman" panose="02020603050405020304" pitchFamily="18" charset="0"/>
-                <a:cs typeface="Times New Roman" panose="02020603050405020304" pitchFamily="18" charset="0"/>
-              </a:rPr>
-              <a:t> – How many actual positives are correctly identified</a:t>
-            </a:r>
-          </a:p>
-          <a:p>
-            <a:r>
-              <a:rPr lang="en-US" sz="2400" b="1" dirty="0" smtClean="0">
-                <a:latin typeface="Times New Roman" panose="02020603050405020304" pitchFamily="18" charset="0"/>
-                <a:cs typeface="Times New Roman" panose="02020603050405020304" pitchFamily="18" charset="0"/>
-              </a:rPr>
-              <a:t>F1-Score</a:t>
-            </a:r>
-            <a:r>
-              <a:rPr lang="en-US" sz="2400" dirty="0" smtClean="0">
-                <a:latin typeface="Times New Roman" panose="02020603050405020304" pitchFamily="18" charset="0"/>
-                <a:cs typeface="Times New Roman" panose="02020603050405020304" pitchFamily="18" charset="0"/>
-              </a:rPr>
-              <a:t> – Balance between Precision and Recall</a:t>
-            </a:r>
-          </a:p>
-          <a:p>
-            <a:pPr marL="342900" indent="-342900">
-              <a:buFont typeface="Arial" panose="020B0604020202020204" pitchFamily="34" charset="0"/>
-              <a:buChar char="•"/>
-            </a:pPr>
-            <a:r>
-              <a:rPr lang="en-US" sz="2400" dirty="0" smtClean="0">
-                <a:latin typeface="Times New Roman" panose="02020603050405020304" pitchFamily="18" charset="0"/>
-                <a:cs typeface="Times New Roman" panose="02020603050405020304" pitchFamily="18" charset="0"/>
-              </a:rPr>
-              <a:t>These metrics help us understand whether the model is reliable and well-balanced.</a:t>
-            </a:r>
-            <a:endParaRPr lang="en-US" sz="2400" dirty="0">
+            <a:r>
+              <a:rPr lang="en-IN" sz="2000" b="1" dirty="0" smtClean="0">
+                <a:latin typeface="Times New Roman" panose="02020603050405020304" pitchFamily="18" charset="0"/>
+                <a:cs typeface="Times New Roman" panose="02020603050405020304" pitchFamily="18" charset="0"/>
+              </a:rPr>
+              <a:t>Week 9</a:t>
+            </a:r>
+            <a:endParaRPr lang="en-IN" sz="2000" b="1" dirty="0">
               <a:latin typeface="Times New Roman" panose="02020603050405020304" pitchFamily="18" charset="0"/>
               <a:cs typeface="Times New Roman" panose="02020603050405020304" pitchFamily="18" charset="0"/>
             </a:endParaRPr>
@@ -9648,14 +9491,14 @@
       </p:sp>
       <p:sp>
         <p:nvSpPr>
-          <p:cNvPr id="3" name="TextBox 2"/>
+          <p:cNvPr id="5" name="TextBox 4"/>
           <p:cNvSpPr txBox="1"/>
           <p:nvPr/>
         </p:nvSpPr>
         <p:spPr>
-          <a:xfrm>
-            <a:off x="3631096" y="463826"/>
-            <a:ext cx="6400800" cy="954107"/>
+          <a:xfrm rot="10800000" flipH="1" flipV="1">
+            <a:off x="2014330" y="1398103"/>
+            <a:ext cx="6832160" cy="369332"/>
           </a:xfrm>
           <a:prstGeom prst="rect">
             <a:avLst/>
@@ -9669,18 +9512,10 @@
           <a:lstStyle/>
           <a:p>
             <a:r>
-              <a:rPr lang="en-US" sz="2800" b="1" dirty="0">
-                <a:latin typeface="Times New Roman" panose="02020603050405020304" pitchFamily="18" charset="0"/>
-                <a:cs typeface="Times New Roman" panose="02020603050405020304" pitchFamily="18" charset="0"/>
-              </a:rPr>
-              <a:t>Classification Evaluation Metrics</a:t>
-            </a:r>
-          </a:p>
-          <a:p>
-            <a:endParaRPr lang="en-IN" sz="2800" dirty="0">
-              <a:latin typeface="Times New Roman" panose="02020603050405020304" pitchFamily="18" charset="0"/>
-              <a:cs typeface="Times New Roman" panose="02020603050405020304" pitchFamily="18" charset="0"/>
-            </a:endParaRPr>
+              <a:rPr lang="en-IN" dirty="0" smtClean="0"/>
+              <a:t>f</a:t>
+            </a:r>
+            <a:endParaRPr lang="en-IN" dirty="0"/>
           </a:p>
         </p:txBody>
       </p:sp>

</xml_diff>